<commit_message>
Make EDFIP slides client-facing.
Remove screening language, harsh internal phrasing, and presenter-only chrome from the deck. Rebuild the PowerPoint from the same copy.

Co-authored-by: Eyuren Hanson <hansoneyuren@gmail.com>
</commit_message>
<xml_diff>
--- a/edfip-screening/EDFIP_Screening_Dexta.pptx
+++ b/edfip-screening/EDFIP_Screening_Dexta.pptx
@@ -3175,7 +3175,7 @@
                 </a:solidFill>
                 <a:latin typeface="Calibri"/>
               </a:rPr>
-              <a:t>EMERAID INTERNATIONAL GROUP  ·  SCREENING</a:t>
+              <a:t>EMERAID INTERNATIONAL GROUP  ·  EDFIP</a:t>
             </a:r>
           </a:p>
         </p:txBody>
@@ -3413,7 +3413,7 @@
                 </a:solidFill>
                 <a:latin typeface="Calibri"/>
               </a:rPr>
-              <a:t>FIELD REALITY</a:t>
+              <a:t>FIELD OPERATIONS</a:t>
             </a:r>
           </a:p>
         </p:txBody>
@@ -3448,7 +3448,7 @@
                 </a:solidFill>
                 <a:latin typeface="Georgia"/>
               </a:rPr>
-              <a:t>The meeting under the tree still counts.</a:t>
+              <a:t>Works in the field with no network.</a:t>
             </a:r>
           </a:p>
         </p:txBody>
@@ -3483,7 +3483,7 @@
                 </a:solidFill>
                 <a:latin typeface="Calibri"/>
               </a:rPr>
-              <a:t>Dexta Synergy Services  ·  Confidential screening</a:t>
+              <a:t>Dexta Synergy Services  ·  EDFIP</a:t>
             </a:r>
           </a:p>
         </p:txBody>
@@ -3771,7 +3771,7 @@
                 </a:solidFill>
                 <a:latin typeface="Calibri"/>
               </a:rPr>
-              <a:t>Dexta Synergy Services  ·  Confidential screening</a:t>
+              <a:t>Dexta Synergy Services  ·  EDFIP</a:t>
             </a:r>
           </a:p>
         </p:txBody>
@@ -4091,7 +4091,7 @@
                 </a:solidFill>
                 <a:latin typeface="Calibri"/>
               </a:rPr>
-              <a:t>Dexta Synergy Services  ·  Confidential screening</a:t>
+              <a:t>Dexta Synergy Services  ·  EDFIP</a:t>
             </a:r>
           </a:p>
         </p:txBody>
@@ -4367,7 +4367,7 @@
                 </a:solidFill>
                 <a:latin typeface="Calibri"/>
               </a:rPr>
-              <a:t>Dexta Synergy Services  ·  Confidential screening</a:t>
+              <a:t>Dexta Synergy Services  ·  EDFIP</a:t>
             </a:r>
           </a:p>
         </p:txBody>
@@ -4510,8 +4510,8 @@
                 <a:latin typeface="Calibri"/>
               </a:rPr>
               <a:t>PAYGO AT MONTH 6
-12% on Deliverable 5.
-Cash follows the differentiator.</a:t>
+12% on accepted Deliverable 5.
+Payment follows a working PayGo release.</a:t>
             </a:r>
           </a:p>
         </p:txBody>
@@ -4644,7 +4644,7 @@
                 </a:solidFill>
                 <a:latin typeface="Calibri"/>
               </a:rPr>
-              <a:t>THE POINT OF THE WHOLE TOR</a:t>
+              <a:t>OWNERSHIP AND HANDOVER</a:t>
             </a:r>
           </a:p>
         </p:txBody>
@@ -4679,7 +4679,8 @@
                 </a:solidFill>
                 <a:latin typeface="Georgia"/>
               </a:rPr>
-              <a:t>Emeraid ends this project free.</a:t>
+              <a:t>Emeraid owns the platform —
+and can run it independently.</a:t>
             </a:r>
           </a:p>
         </p:txBody>
@@ -4714,7 +4715,7 @@
                 </a:solidFill>
                 <a:latin typeface="Calibri"/>
               </a:rPr>
-              <a:t>Dexta Synergy Services  ·  Confidential screening</a:t>
+              <a:t>Dexta Synergy Services  ·  EDFIP</a:t>
             </a:r>
           </a:p>
         </p:txBody>
@@ -4788,7 +4789,7 @@
                 </a:solidFill>
                 <a:latin typeface="Calibri"/>
               </a:rPr>
-              <a:t>•  Free to operate, modify, extend, sell, onboard tenants.</a:t>
+              <a:t>•  Free to operate, modify, extend, sell, and onboard tenants.</a:t>
             </a:r>
           </a:p>
           <a:p>
@@ -4804,7 +4805,7 @@
                 </a:solidFill>
                 <a:latin typeface="Calibri"/>
               </a:rPr>
-              <a:t>•  Free to replace us. Repository is yours from day one.</a:t>
+              <a:t>•  Source repository is Emeraid’s from day one. Independent maintenance after handover.</a:t>
             </a:r>
           </a:p>
           <a:p>
@@ -4932,7 +4933,7 @@
                 </a:solidFill>
                 <a:latin typeface="Calibri"/>
               </a:rPr>
-              <a:t>NO AWARD HAS BEEN MADE — WE KNOW</a:t>
+              <a:t>THANK YOU</a:t>
             </a:r>
           </a:p>
         </p:txBody>
@@ -4967,8 +4968,8 @@
                 </a:solidFill>
                 <a:latin typeface="Georgia"/>
               </a:rPr>
-              <a:t>We would like your
-assessment points.</a:t>
+              <a:t>We welcome your
+questions.</a:t>
             </a:r>
           </a:p>
         </p:txBody>
@@ -5003,8 +5004,8 @@
                 </a:solidFill>
                 <a:latin typeface="Calibri"/>
               </a:rPr>
-              <a:t>Architecture, PayGo, CRM, capacity, price, collaboration —
-we will answer what you actually found, not a generic pitch.</a:t>
+              <a:t>Architecture, PayGo, CRM, delivery capacity, commercial terms,
+and any collaboration model you wish to explore.</a:t>
             </a:r>
           </a:p>
         </p:txBody>
@@ -5170,7 +5171,7 @@
                 </a:solidFill>
                 <a:latin typeface="Calibri"/>
               </a:rPr>
-              <a:t>WHAT EMERAID IS PROCURING</a:t>
+              <a:t>WHAT EMERAID IS BUILDING</a:t>
             </a:r>
           </a:p>
         </p:txBody>
@@ -5241,7 +5242,7 @@
                 </a:solidFill>
                 <a:latin typeface="Calibri"/>
               </a:rPr>
-              <a:t>Dexta Synergy Services  ·  Confidential screening</a:t>
+              <a:t>Dexta Synergy Services  ·  EDFIP</a:t>
             </a:r>
           </a:p>
         </p:txBody>
@@ -5449,7 +5450,7 @@
                 </a:solidFill>
                 <a:latin typeface="Calibri"/>
               </a:rPr>
-              <a:t>FIRST PRODUCTION RELEASE — OR THE BID IS DEAD</a:t>
+              <a:t>FIRST PRODUCTION RELEASE</a:t>
             </a:r>
           </a:p>
         </p:txBody>
@@ -5519,7 +5520,7 @@
                 </a:solidFill>
                 <a:latin typeface="Calibri"/>
               </a:rPr>
-              <a:t>Dexta Synergy Services  ·  Confidential screening</a:t>
+              <a:t>Dexta Synergy Services  ·  EDFIP</a:t>
             </a:r>
           </a:p>
         </p:txBody>
@@ -5593,7 +5594,7 @@
                 </a:solidFill>
                 <a:latin typeface="Calibri"/>
               </a:rPr>
-              <a:t>•  Full CRM — Customer Relationship Management: leads, visits, complaints, campaigns. Not “add customer.”</a:t>
+              <a:t>•  Full CRM — Customer Relationship Management: leads, visits, complaints, campaigns — not a registration screen.</a:t>
             </a:r>
           </a:p>
           <a:p>
@@ -5625,7 +5626,7 @@
                 </a:solidFill>
                 <a:latin typeface="Calibri"/>
               </a:rPr>
-              <a:t>•  Also mandatory: real offline field app, plus customer web and Android app.</a:t>
+              <a:t>•  Also in first release: offline field app, plus customer web and Android app.</a:t>
             </a:r>
           </a:p>
         </p:txBody>
@@ -5792,7 +5793,7 @@
                 </a:solidFill>
                 <a:latin typeface="Calibri"/>
               </a:rPr>
-              <a:t>Dexta Synergy Services  ·  Confidential screening</a:t>
+              <a:t>Dexta Synergy Services  ·  EDFIP</a:t>
             </a:r>
           </a:p>
         </p:txBody>
@@ -5938,10 +5939,10 @@
                 </a:solidFill>
                 <a:latin typeface="Calibri"/>
               </a:rPr>
-              <a:t>IF THEY STOP PAYING YOU
-Suspend tenant. Access locked.
-Data stays. Restore when the
-licence is current. Not a wipe.</a:t>
+              <a:t>IF A LICENCE LAPSES
+The institution can be suspended.
+Access locked. Data retained.
+Restored when the licence is current.</a:t>
             </a:r>
           </a:p>
         </p:txBody>
@@ -6107,7 +6108,7 @@
                 </a:solidFill>
                 <a:latin typeface="Calibri"/>
               </a:rPr>
-              <a:t>Dexta Synergy Services  ·  Confidential screening</a:t>
+              <a:t>Dexta Synergy Services  ·  EDFIP</a:t>
             </a:r>
           </a:p>
         </p:txBody>
@@ -6429,7 +6430,7 @@
                 </a:solidFill>
                 <a:latin typeface="Calibri"/>
               </a:rPr>
-              <a:t>Dexta Synergy Services  ·  Confidential screening</a:t>
+              <a:t>Dexta Synergy Services  ·  EDFIP</a:t>
             </a:r>
           </a:p>
         </p:txBody>
@@ -6519,7 +6520,7 @@
                 </a:solidFill>
                 <a:latin typeface="Calibri"/>
               </a:rPr>
-              <a:t>•  Emeraid-owned modules — loans, savings, VSLA, cooperatives, PayGo, agency. Odoo does not have an MFI core.</a:t>
+              <a:t>•  Emeraid-owned modules — loans, savings, VSLA, cooperatives, PayGo, agency. Purpose-built for EDFIP.</a:t>
             </a:r>
           </a:p>
           <a:p>
@@ -6535,7 +6536,7 @@
                 </a:solidFill>
                 <a:latin typeface="Calibri"/>
               </a:rPr>
-              <a:t>•  FastAPI inside Odoo — public API, webhooks, mobile sync. Odoo’s XML-RPC fails your security and docs rules.</a:t>
+              <a:t>•  FastAPI inside Odoo — public API, webhooks, mobile sync. Meets the TOR security and documentation standard.</a:t>
             </a:r>
           </a:p>
           <a:p>
@@ -6663,7 +6664,7 @@
                 </a:solidFill>
                 <a:latin typeface="Calibri"/>
               </a:rPr>
-              <a:t>HONEST SPLIT</a:t>
+              <a:t>IMPLEMENTATION APPROACH</a:t>
             </a:r>
           </a:p>
         </p:txBody>
@@ -6698,7 +6699,8 @@
                 </a:solidFill>
                 <a:latin typeface="Georgia"/>
               </a:rPr>
-              <a:t>Odoo is modular. It is not magic.</a:t>
+              <a:t>What the foundation provides —
+and what we build.</a:t>
             </a:r>
           </a:p>
         </p:txBody>
@@ -6733,7 +6735,7 @@
                 </a:solidFill>
                 <a:latin typeface="Calibri"/>
               </a:rPr>
-              <a:t>Dexta Synergy Services  ·  Confidential screening</a:t>
+              <a:t>Dexta Synergy Services  ·  EDFIP</a:t>
             </a:r>
           </a:p>
         </p:txBody>
@@ -7013,7 +7015,7 @@
                 </a:solidFill>
                 <a:latin typeface="Calibri"/>
               </a:rPr>
-              <a:t>Dexta Synergy Services  ·  Confidential screening</a:t>
+              <a:t>Dexta Synergy Services  ·  EDFIP</a:t>
             </a:r>
           </a:p>
         </p:txBody>
@@ -7333,7 +7335,7 @@
                 </a:solidFill>
                 <a:latin typeface="Calibri"/>
               </a:rPr>
-              <a:t>Dexta Synergy Services  ·  Confidential screening</a:t>
+              <a:t>Dexta Synergy Services  ·  EDFIP</a:t>
             </a:r>
           </a:p>
         </p:txBody>
@@ -7458,7 +7460,7 @@
                 </a:solidFill>
                 <a:latin typeface="Calibri"/>
               </a:rPr>
-              <a:t>•  Month 6 early operational release: registry + asset-linked loan + first connector + token request + delivery + audit. Not final acceptance.</a:t>
+              <a:t>•  Month 6 early operational release: registry, asset-linked loan, first connector, token request, delivery and audit — ahead of full go-live.</a:t>
             </a:r>
           </a:p>
           <a:p>

</xml_diff>

<commit_message>
Rewrite opening slides: product understanding, four commitments, first-release scope.
Replace the 'not buying' headline with a client-facing reading of EDFIP, list the four delivery commitments, and group the specified platform capabilities.

Co-authored-by: Eyuren Hanson <hansoneyuren@gmail.com>
</commit_message>
<xml_diff>
--- a/edfip-screening/EDFIP_Screening_Dexta.pptx
+++ b/edfip-screening/EDFIP_Screening_Dexta.pptx
@@ -3153,7 +3153,7 @@
         </p:nvSpPr>
         <p:spPr>
           <a:xfrm>
-            <a:off x="640080" y="411480"/>
+            <a:off x="640080" y="365760"/>
             <a:ext cx="10972800" cy="320040"/>
           </a:xfrm>
           <a:prstGeom prst="rect">
@@ -3175,7 +3175,7 @@
                 </a:solidFill>
                 <a:latin typeface="Calibri"/>
               </a:rPr>
-              <a:t>EMERAID INTERNATIONAL GROUP  ·  EDFIP</a:t>
+              <a:t>HOW WE READ THE ASSIGNMENT</a:t>
             </a:r>
           </a:p>
         </p:txBody>
@@ -3188,8 +3188,8 @@
         </p:nvSpPr>
         <p:spPr>
           <a:xfrm>
-            <a:off x="640080" y="1463040"/>
-            <a:ext cx="10972800" cy="2011680"/>
+            <a:off x="640080" y="822960"/>
+            <a:ext cx="10972800" cy="1371600"/>
           </a:xfrm>
           <a:prstGeom prst="rect">
             <a:avLst/>
@@ -3204,14 +3204,14 @@
           <a:p>
             <a:pPr algn="l"/>
             <a:r>
-              <a:rPr sz="4400" b="0">
+              <a:rPr sz="3400" b="0">
                 <a:solidFill>
                   <a:srgbClr val="F4F0E6"/>
                 </a:solidFill>
                 <a:latin typeface="Georgia"/>
               </a:rPr>
-              <a:t>You are not buying
-a microfinance app.</a:t>
+              <a:t>We understand the product
+Emeraid is building.</a:t>
             </a:r>
           </a:p>
         </p:txBody>
@@ -3224,8 +3224,8 @@
         </p:nvSpPr>
         <p:spPr>
           <a:xfrm>
-            <a:off x="640080" y="3931920"/>
-            <a:ext cx="9144000" cy="1097280"/>
+            <a:off x="640080" y="2377440"/>
+            <a:ext cx="10515600" cy="1645920"/>
           </a:xfrm>
           <a:prstGeom prst="rect">
             <a:avLst/>
@@ -3240,14 +3240,13 @@
           <a:p>
             <a:pPr algn="l"/>
             <a:r>
-              <a:rPr sz="2200" b="0">
+              <a:rPr sz="1800" b="0">
                 <a:solidFill>
                   <a:srgbClr val="A8B3AA"/>
                 </a:solidFill>
                 <a:latin typeface="Calibri"/>
               </a:rPr>
-              <a:t>You are building a product company.
-We are here to put the operating system underneath it.</a:t>
+              <a:t>Not a basic microfinance application. A commercialisable, multi-tenant Digital Financial Inclusion Operating System — EDFIP — that Emeraid will own, control, brand and sell to third-party institutions.</a:t>
             </a:r>
           </a:p>
         </p:txBody>
@@ -3260,8 +3259,44 @@
         </p:nvSpPr>
         <p:spPr>
           <a:xfrm>
+            <a:off x="640080" y="4206240"/>
+            <a:ext cx="10972800" cy="1463040"/>
+          </a:xfrm>
+          <a:prstGeom prst="rect">
+            <a:avLst/>
+          </a:prstGeom>
+          <a:noFill/>
+        </p:spPr>
+        <p:txBody>
+          <a:bodyPr wrap="square">
+            <a:spAutoFit/>
+          </a:bodyPr>
+          <a:lstStyle/>
+          <a:p>
+            <a:pPr algn="l"/>
+            <a:r>
+              <a:rPr sz="1600" b="0">
+                <a:solidFill>
+                  <a:srgbClr val="F4F0E6"/>
+                </a:solidFill>
+                <a:latin typeface="Calibri"/>
+              </a:rPr>
+              <a:t>Microfinance institutions   ·   Cooperatives   ·   VSLA networks
+NGOs and programmes   ·   Solar / PayGo operators   ·   Agency banking networks</a:t>
+            </a:r>
+          </a:p>
+        </p:txBody>
+      </p:sp>
+      <p:sp>
+        <p:nvSpPr>
+          <p:cNvPr id="7" name="TextBox 6"/>
+          <p:cNvSpPr txBox="1"/>
+          <p:nvPr/>
+        </p:nvSpPr>
+        <p:spPr>
+          <a:xfrm>
             <a:off x="640080" y="5943600"/>
-            <a:ext cx="9144000" cy="365760"/>
+            <a:ext cx="9144000" cy="320040"/>
           </a:xfrm>
           <a:prstGeom prst="rect">
             <a:avLst/>
@@ -3276,20 +3311,55 @@
           <a:p>
             <a:pPr algn="l"/>
             <a:r>
-              <a:rPr sz="1600" b="0">
+              <a:rPr sz="1500" b="0">
                 <a:solidFill>
                   <a:srgbClr val="C4A056"/>
                 </a:solidFill>
                 <a:latin typeface="Calibri"/>
               </a:rPr>
-              <a:t>Hanson Eyuren  ·  Lead Developer  ·  Dexta Synergy Services</a:t>
-            </a:r>
-          </a:p>
-        </p:txBody>
-      </p:sp>
-      <p:sp>
-        <p:nvSpPr>
-          <p:cNvPr id="7" name="TextBox 6"/>
+              <a:t>Every architectural and commercial choice in our proposal follows from that reality.</a:t>
+            </a:r>
+          </a:p>
+        </p:txBody>
+      </p:sp>
+      <p:sp>
+        <p:nvSpPr>
+          <p:cNvPr id="8" name="TextBox 7"/>
+          <p:cNvSpPr txBox="1"/>
+          <p:nvPr/>
+        </p:nvSpPr>
+        <p:spPr>
+          <a:xfrm>
+            <a:off x="640080" y="6446520"/>
+            <a:ext cx="7315200" cy="228600"/>
+          </a:xfrm>
+          <a:prstGeom prst="rect">
+            <a:avLst/>
+          </a:prstGeom>
+          <a:noFill/>
+        </p:spPr>
+        <p:txBody>
+          <a:bodyPr wrap="square">
+            <a:spAutoFit/>
+          </a:bodyPr>
+          <a:lstStyle/>
+          <a:p>
+            <a:pPr algn="l"/>
+            <a:r>
+              <a:rPr sz="1100" b="0">
+                <a:solidFill>
+                  <a:srgbClr val="A8B3AA"/>
+                </a:solidFill>
+                <a:latin typeface="Calibri"/>
+              </a:rPr>
+              <a:t>Dexta Synergy Services  ·  EDFIP</a:t>
+            </a:r>
+          </a:p>
+        </p:txBody>
+      </p:sp>
+      <p:sp>
+        <p:nvSpPr>
+          <p:cNvPr id="9" name="TextBox 8"/>
           <p:cNvSpPr txBox="1"/>
           <p:nvPr/>
         </p:nvSpPr>
@@ -5171,7 +5241,7 @@
                 </a:solidFill>
                 <a:latin typeface="Calibri"/>
               </a:rPr>
-              <a:t>WHAT EMERAID IS BUILDING</a:t>
+              <a:t>WHAT THIS ENGAGEMENT MUST PROTECT</a:t>
             </a:r>
           </a:p>
         </p:txBody>
@@ -5206,8 +5276,8 @@
                 </a:solidFill>
                 <a:latin typeface="Georgia"/>
               </a:rPr>
-              <a:t>A commercial operating system,
-owned by Emeraid.</a:t>
+              <a:t>Four commitments that matter
+to Emeraid.</a:t>
             </a:r>
           </a:p>
         </p:txBody>
@@ -5290,71 +5360,81 @@
         </p:nvSpPr>
         <p:spPr>
           <a:xfrm>
-            <a:off x="640080" y="2468880"/>
-            <a:ext cx="5212080" cy="2926080"/>
-          </a:xfrm>
-          <a:prstGeom prst="rect">
-            <a:avLst/>
-          </a:prstGeom>
-          <a:noFill/>
-        </p:spPr>
-        <p:txBody>
-          <a:bodyPr wrap="square">
-            <a:spAutoFit/>
-          </a:bodyPr>
-          <a:lstStyle/>
-          <a:p>
-            <a:pPr algn="l"/>
-            <a:r>
-              <a:rPr sz="1800" b="0">
-                <a:solidFill>
-                  <a:srgbClr val="A8B3AA"/>
-                </a:solidFill>
-                <a:latin typeface="Calibri"/>
-              </a:rPr>
-              <a:t>NOT THIS
-One institution. One database.
-A vendor they cannot replace.
-A tool they cannot resell.</a:t>
-            </a:r>
-          </a:p>
-        </p:txBody>
-      </p:sp>
-      <p:sp>
-        <p:nvSpPr>
-          <p:cNvPr id="8" name="TextBox 7"/>
-          <p:cNvSpPr txBox="1"/>
-          <p:nvPr/>
-        </p:nvSpPr>
-        <p:spPr>
-          <a:xfrm>
-            <a:off x="6217920" y="2468880"/>
-            <a:ext cx="5212080" cy="2926080"/>
-          </a:xfrm>
-          <a:prstGeom prst="rect">
-            <a:avLst/>
-          </a:prstGeom>
-          <a:noFill/>
-        </p:spPr>
-        <p:txBody>
-          <a:bodyPr wrap="square">
-            <a:spAutoFit/>
-          </a:bodyPr>
-          <a:lstStyle/>
-          <a:p>
-            <a:pPr algn="l"/>
-            <a:r>
-              <a:rPr sz="1800" b="0">
+            <a:off x="640080" y="2377440"/>
+            <a:ext cx="10972800" cy="3840480"/>
+          </a:xfrm>
+          <a:prstGeom prst="rect">
+            <a:avLst/>
+          </a:prstGeom>
+          <a:noFill/>
+        </p:spPr>
+        <p:txBody>
+          <a:bodyPr wrap="square">
+            <a:spAutoFit/>
+          </a:bodyPr>
+          <a:lstStyle/>
+          <a:p>
+            <a:pPr>
+              <a:spcAft>
+                <a:spcPts val="1200"/>
+              </a:spcAft>
+            </a:pPr>
+            <a:r>
+              <a:rPr sz="1700">
                 <a:solidFill>
                   <a:srgbClr val="F4F0E6"/>
                 </a:solidFill>
                 <a:latin typeface="Calibri"/>
               </a:rPr>
-              <a:t>THIS — EDFIP
-Emeraid Digital Financial Inclusion Platform.
-Many institutions. Emeraid’s branding,
-price list and roadmap. Custom code
-Emeraid owns.</a:t>
+              <a:t>•  Full CRM in the first production release — the complete relationship, not a registration screen.</a:t>
+            </a:r>
+          </a:p>
+          <a:p>
+            <a:pPr>
+              <a:spcAft>
+                <a:spcPts val="1200"/>
+              </a:spcAft>
+            </a:pPr>
+            <a:r>
+              <a:rPr sz="1700">
+                <a:solidFill>
+                  <a:srgbClr val="F4F0E6"/>
+                </a:solidFill>
+                <a:latin typeface="Calibri"/>
+              </a:rPr>
+              <a:t>•  Green Asset Finance and PayGo in the first release, with an Early Operational Release by Month 6.</a:t>
+            </a:r>
+          </a:p>
+          <a:p>
+            <a:pPr>
+              <a:spcAft>
+                <a:spcPts val="1200"/>
+              </a:spcAft>
+            </a:pPr>
+            <a:r>
+              <a:rPr sz="1700">
+                <a:solidFill>
+                  <a:srgbClr val="F4F0E6"/>
+                </a:solidFill>
+                <a:latin typeface="Calibri"/>
+              </a:rPr>
+              <a:t>•  Emeraid’s ability to operate, modify, commercialise and maintain the platform independently.</a:t>
+            </a:r>
+          </a:p>
+          <a:p>
+            <a:pPr>
+              <a:spcAft>
+                <a:spcPts val="1200"/>
+              </a:spcAft>
+            </a:pPr>
+            <a:r>
+              <a:rPr sz="1700">
+                <a:solidFill>
+                  <a:srgbClr val="F4F0E6"/>
+                </a:solidFill>
+                <a:latin typeface="Calibri"/>
+              </a:rPr>
+              <a:t>•  A realistic 12-month delivery plan with testing and acceptance evidence.</a:t>
             </a:r>
           </a:p>
         </p:txBody>
@@ -5450,7 +5530,7 @@
                 </a:solidFill>
                 <a:latin typeface="Calibri"/>
               </a:rPr>
-              <a:t>FIRST PRODUCTION RELEASE</a:t>
+              <a:t>FIRST-RELEASE SCOPE</a:t>
             </a:r>
           </a:p>
         </p:txBody>
@@ -5485,7 +5565,7 @@
                 </a:solidFill>
                 <a:latin typeface="Georgia"/>
               </a:rPr>
-              <a:t>Two things that cannot wait.</a:t>
+              <a:t>The platform Emeraid specified.</a:t>
             </a:r>
           </a:p>
         </p:txBody>
@@ -5568,65 +5648,146 @@
         </p:nvSpPr>
         <p:spPr>
           <a:xfrm>
-            <a:off x="640080" y="2377440"/>
-            <a:ext cx="10972800" cy="3840480"/>
-          </a:xfrm>
-          <a:prstGeom prst="rect">
-            <a:avLst/>
-          </a:prstGeom>
-          <a:noFill/>
-        </p:spPr>
-        <p:txBody>
-          <a:bodyPr wrap="square">
-            <a:spAutoFit/>
-          </a:bodyPr>
-          <a:lstStyle/>
-          <a:p>
-            <a:pPr>
-              <a:spcAft>
-                <a:spcPts val="1200"/>
-              </a:spcAft>
-            </a:pPr>
-            <a:r>
-              <a:rPr sz="1800">
+            <a:off x="640080" y="2240280"/>
+            <a:ext cx="3657600" cy="3931920"/>
+          </a:xfrm>
+          <a:prstGeom prst="rect">
+            <a:avLst/>
+          </a:prstGeom>
+          <a:noFill/>
+        </p:spPr>
+        <p:txBody>
+          <a:bodyPr wrap="square">
+            <a:spAutoFit/>
+          </a:bodyPr>
+          <a:lstStyle/>
+          <a:p>
+            <a:pPr algn="l"/>
+            <a:r>
+              <a:rPr sz="1400" b="0">
                 <a:solidFill>
                   <a:srgbClr val="F4F0E6"/>
                 </a:solidFill>
                 <a:latin typeface="Calibri"/>
               </a:rPr>
-              <a:t>•  Full CRM — Customer Relationship Management: leads, visits, complaints, campaigns — not a registration screen.</a:t>
-            </a:r>
-          </a:p>
-          <a:p>
-            <a:pPr>
-              <a:spcAft>
-                <a:spcPts val="1200"/>
-              </a:spcAft>
-            </a:pPr>
-            <a:r>
-              <a:rPr sz="1800">
+              <a:t>OPERATE
+Multi-tenant SaaS Emeraid can sell
+Clients, members and KYC
+Full CRM
+Roles, maker-checker and audit</a:t>
+            </a:r>
+          </a:p>
+        </p:txBody>
+      </p:sp>
+      <p:sp>
+        <p:nvSpPr>
+          <p:cNvPr id="8" name="TextBox 7"/>
+          <p:cNvSpPr txBox="1"/>
+          <p:nvPr/>
+        </p:nvSpPr>
+        <p:spPr>
+          <a:xfrm>
+            <a:off x="4389120" y="2240280"/>
+            <a:ext cx="3657600" cy="3931920"/>
+          </a:xfrm>
+          <a:prstGeom prst="rect">
+            <a:avLst/>
+          </a:prstGeom>
+          <a:noFill/>
+        </p:spPr>
+        <p:txBody>
+          <a:bodyPr wrap="square">
+            <a:spAutoFit/>
+          </a:bodyPr>
+          <a:lstStyle/>
+          <a:p>
+            <a:pPr algn="l"/>
+            <a:r>
+              <a:rPr sz="1400" b="0">
                 <a:solidFill>
                   <a:srgbClr val="F4F0E6"/>
                 </a:solidFill>
                 <a:latin typeface="Calibri"/>
               </a:rPr>
-              <a:t>•  Green Asset Finance + PayGo — Pay-As-You-Go: the customer pays, the solar / freezer / pump unlocks. Early operational slice before full go-live.</a:t>
-            </a:r>
-          </a:p>
-          <a:p>
-            <a:pPr>
-              <a:spcAft>
-                <a:spcPts val="1200"/>
-              </a:spcAft>
-            </a:pPr>
-            <a:r>
-              <a:rPr sz="1800">
+              <a:t>LEND AND SAVE
+Loan management
+Savings, including esusu / ajo
+Accounting and general ledger
+Cooperatives and VSLA groups</a:t>
+            </a:r>
+          </a:p>
+        </p:txBody>
+      </p:sp>
+      <p:sp>
+        <p:nvSpPr>
+          <p:cNvPr id="9" name="TextBox 8"/>
+          <p:cNvSpPr txBox="1"/>
+          <p:nvPr/>
+        </p:nvSpPr>
+        <p:spPr>
+          <a:xfrm>
+            <a:off x="8138160" y="2240280"/>
+            <a:ext cx="3657600" cy="3931920"/>
+          </a:xfrm>
+          <a:prstGeom prst="rect">
+            <a:avLst/>
+          </a:prstGeom>
+          <a:noFill/>
+        </p:spPr>
+        <p:txBody>
+          <a:bodyPr wrap="square">
+            <a:spAutoFit/>
+          </a:bodyPr>
+          <a:lstStyle/>
+          <a:p>
+            <a:pPr algn="l"/>
+            <a:r>
+              <a:rPr sz="1400" b="0">
                 <a:solidFill>
                   <a:srgbClr val="F4F0E6"/>
                 </a:solidFill>
                 <a:latin typeface="Calibri"/>
               </a:rPr>
-              <a:t>•  Also in first release: offline field app, plus customer web and Android app.</a:t>
+              <a:t>DIFFERENTIATE
+Green Asset Finance and PayGo
+Device-linked credit — not cash-only
+Agency banking and tellering
+Digital payments and collections</a:t>
+            </a:r>
+          </a:p>
+        </p:txBody>
+      </p:sp>
+      <p:sp>
+        <p:nvSpPr>
+          <p:cNvPr id="10" name="TextBox 9"/>
+          <p:cNvSpPr txBox="1"/>
+          <p:nvPr/>
+        </p:nvSpPr>
+        <p:spPr>
+          <a:xfrm>
+            <a:off x="640080" y="5806440"/>
+            <a:ext cx="10972800" cy="502920"/>
+          </a:xfrm>
+          <a:prstGeom prst="rect">
+            <a:avLst/>
+          </a:prstGeom>
+          <a:noFill/>
+        </p:spPr>
+        <p:txBody>
+          <a:bodyPr wrap="square">
+            <a:spAutoFit/>
+          </a:bodyPr>
+          <a:lstStyle/>
+          <a:p>
+            <a:pPr algn="l"/>
+            <a:r>
+              <a:rPr sz="1300" b="0">
+                <a:solidFill>
+                  <a:srgbClr val="A8B3AA"/>
+                </a:solidFill>
+                <a:latin typeface="Calibri"/>
+              </a:rPr>
+              <a:t>Reach: offline field app · customer web + Android · SMS/email    Prove: dashboards, donor reporting, partner APIs, first-tenant migration</a:t>
             </a:r>
           </a:p>
         </p:txBody>

</xml_diff>